<commit_message>
fix(institucional): remove referencias a CAPES e define Itaipu Parquetec como entidade financiadora em todo o sistema e apresentacoes
</commit_message>
<xml_diff>
--- a/Apresentacao_Simposio_7min_SAREL.pptx
+++ b/Apresentacao_Simposio_7min_SAREL.pptx
@@ -1129,7 +1129,7 @@
           </a:p>
           <a:p>
             <a:r>
-              <a:t>Agradeço ao PPGTCA da UTFPR Campus Medianeira, ao meu orientador, à CAPES pelo apoio financeiro e a todos vocês pela atenção. Muito obrigado!</a:t>
+              <a:t>Agradeço ao PPGTCA da UTFPR Campus Medianeira, ao meu orientador, ao Itaipu Parquetec pelo financiamento e apoio à pesquisa, e a todos vocês pela atenção. Muito obrigado!</a:t>
             </a:r>
           </a:p>
         </p:txBody>
@@ -4286,7 +4286,7 @@
               </a:defRPr>
             </a:pPr>
             <a:r>
-              <a:t>Apoio Institucional: PPGTCA / UTFPR  •  CAPES (Código de Financiamento 001)</a:t>
+              <a:t>Apoio Institucional e Financiamento: PPGTCA / UTFPR  •  Itaipu Parquetec</a:t>
             </a:r>
           </a:p>
         </p:txBody>
@@ -4392,7 +4392,7 @@
               </a:defRPr>
             </a:pPr>
             <a:r>
-              <a:t>SIMPÓSIO ESTUDANTIL • PPGTCA / UTFPR MEDIANEIRA • APOIO CAPES</a:t>
+              <a:t>SIMPÓSIO ESTUDANTIL • PPGTCA / UTFPR MEDIANEIRA • APOIO ITAIPU PARQUETEC</a:t>
             </a:r>
           </a:p>
         </p:txBody>
@@ -5186,7 +5186,7 @@
               </a:defRPr>
             </a:pPr>
             <a:r>
-              <a:t>SIMPÓSIO ESTUDANTIL • PPGTCA / UTFPR MEDIANEIRA • APOIO CAPES</a:t>
+              <a:t>SIMPÓSIO ESTUDANTIL • PPGTCA / UTFPR MEDIANEIRA • APOIO ITAIPU PARQUETEC</a:t>
             </a:r>
           </a:p>
         </p:txBody>
@@ -5994,7 +5994,7 @@
               </a:defRPr>
             </a:pPr>
             <a:r>
-              <a:t>SIMPÓSIO ESTUDANTIL • PPGTCA / UTFPR MEDIANEIRA • APOIO CAPES</a:t>
+              <a:t>SIMPÓSIO ESTUDANTIL • PPGTCA / UTFPR MEDIANEIRA • APOIO ITAIPU PARQUETEC</a:t>
             </a:r>
           </a:p>
         </p:txBody>
@@ -6757,7 +6757,7 @@
               </a:defRPr>
             </a:pPr>
             <a:r>
-              <a:t>SIMPÓSIO ESTUDANTIL • PPGTCA / UTFPR MEDIANEIRA • APOIO CAPES</a:t>
+              <a:t>SIMPÓSIO ESTUDANTIL • PPGTCA / UTFPR MEDIANEIRA • APOIO ITAIPU PARQUETEC</a:t>
             </a:r>
           </a:p>
         </p:txBody>
@@ -7520,7 +7520,7 @@
               </a:defRPr>
             </a:pPr>
             <a:r>
-              <a:t>SIMPÓSIO ESTUDANTIL • PPGTCA / UTFPR MEDIANEIRA • APOIO CAPES</a:t>
+              <a:t>SIMPÓSIO ESTUDANTIL • PPGTCA / UTFPR MEDIANEIRA • APOIO ITAIPU PARQUETEC</a:t>
             </a:r>
           </a:p>
         </p:txBody>
@@ -8328,7 +8328,7 @@
               </a:defRPr>
             </a:pPr>
             <a:r>
-              <a:t>SIMPÓSIO ESTUDANTIL • PPGTCA / UTFPR MEDIANEIRA • APOIO CAPES</a:t>
+              <a:t>SIMPÓSIO ESTUDANTIL • PPGTCA / UTFPR MEDIANEIRA • APOIO ITAIPU PARQUETEC</a:t>
             </a:r>
           </a:p>
         </p:txBody>
@@ -9497,7 +9497,7 @@
               </a:defRPr>
             </a:pPr>
             <a:r>
-              <a:t>Agradecimentos: Programa de Pós-Graduação em Tecnologias Computacionais para o Agronegócio (PPGTCA — UTFPR Campus Medianeira) e Coordenação de Aperfeiçoamento de Pessoal de Nível Superior — Brasil (CAPES) — Código de Financiamento 001.</a:t>
+              <a:t>Agradecimentos: Programa de Pós-Graduação em Tecnologias Computacionais para o Agronegócio (PPGTCA — UTFPR Campus Medianeira) e Itaipu Parquetec pelo financiamento e apoio ao desenvolvimento tecnológico.</a:t>
             </a:r>
             <a:br/>
             <a:r>

</xml_diff>